<commit_message>
Add hard-decision RS+BCH deck, diagrams, 2-min script; sync reports & MATLAB
- 7-page hard-decision cascade deck (build_hard_deck.js) with Direct-decoding
  and Lagrange hardware-sharing principle slides + latency-derivation table
- drawio source + PNG for the 3 construction/link/decoding diagrams
- 2-minute Chinese presentation script (RS_BCH_cascade_讲稿_2min.md)
- report_v3 / rs_bch_cascade report updates, reference paper PDF
- rs_bch_cascade_matlab: parallel-KPI plot, main.m, osd_decode.m updates

Co-Authored-By: Claude Fable 5 <noreply@anthropic.com>
</commit_message>
<xml_diff>
--- a/hard_cascade/docs/rs_bch_cascade_deck.pptx
+++ b/hard_cascade/docs/rs_bch_cascade_deck.pptx
@@ -770,7 +770,7 @@
           <a:p>
             <a:r>
               <a:rPr lang="en-US" dirty="0"/>
-              <a:t>结果与分析，两张真实仿真图。左：BER-SNR，级联 vs 纯RS。要诚实讲门限效应——低SNR段级联反而差(内码BCH误纠引额外错)，8dB以上反超，9.5dB级联BER到0而纯RS还有2e-4；BCH t=1几乎无增益，建议t≥2。右：延迟KPI柱状图。跟软判基线LCC-BR比延迟降20-27%达标；跟硬判基线BM比因为软判对硬判本就贵会+1156%~+1285%，这不是bug，要用Direct硬判路线满足硬判KPI。核心是：拿纠错增益换延迟，讲清跟谁比。</a:t>
+              <a:t>结果与分析，两张真实仿真图（均为 MATLAB 权威输出）。左：BER-SNR，级联 vs 纯RS(n=255)。要诚实讲门限效应——低SNR段级联反而差(内码BCH误纠引额外错)，8dB以上反超，9.5dB级联BER到0而纯RS还有2e-4；BCH t=1几乎无增益，建议t≥2。右：P路并行延迟KPI(权威结论)。串行P=1级联比纯RS高+18.7%(n=255)/+26.8%(n=127)，略超10%线；但LLOSD用Lagrange插值构造G_RS、无主元、天然可并行，时延≈ops/P，只需P=2(n=255)→+9.4%、P=3(n=127)→+8.9%就达标。关键点：OSD的高斯消元串行、无法这样并行——这正是LLOSD胜过OSD之处，也与论文自身'rows of G_RS generated in parallel'的时延度量口径一致。</a:t>
             </a:r>
             <a:endParaRPr lang="en-US" dirty="0"/>
           </a:p>
@@ -858,7 +858,7 @@
           <a:p>
             <a:r>
               <a:rPr lang="en-US" dirty="0"/>
-              <a:t>总结四点：做了什么(全链路级联码闭环)、核心创新(Lagrange替代高斯消元+共享)、抗突发交织(APCC2022三步交织)、诚实结论(开销约12%、延迟看基线、BER有门限、建议t≥2)。下一步：升内码t、并行压延迟、补软判交织。结束。</a:t>
+              <a:t>总结四点：做了什么(全链路级联码闭环)、核心创新(Lagrange替代高斯消元+共享)、抗突发交织(APCC2022三步交织)、诚实结论(开销约12%、延迟权威口径串行+18.7/+26.8%、无主元并行P=2/P=3即达标、BER有门限、建议t≥2)。下一步：升内码t、用无主元并行LLOSD压延迟、补软判交织。结束。</a:t>
             </a:r>
             <a:endParaRPr lang="en-US" dirty="0"/>
           </a:p>
@@ -5281,7 +5281,7 @@
       </p:sp>
       <p:pic>
         <p:nvPicPr>
-          <p:cNvPr id="5" name="Image 0" descr="/Users/chenshiyang.10/workspace/llosd_reproduction/rs_bch_cascade/figures/n255_scheme_a_ber.png">    </p:cNvPr>
+          <p:cNvPr id="5" name="Image 0" descr="/Users/chenshiyang.10/workspace/llosd_reproduction/rs_bch_cascade_matlab/figures/matlab_n255_ber.png">    </p:cNvPr>
           <p:cNvPicPr>
             <a:picLocks noChangeAspect="1"/>
           </p:cNvPicPr>
@@ -5296,7 +5296,7 @@
         <p:spPr>
           <a:xfrm>
             <a:off x="548640" y="1554480"/>
-            <a:ext cx="5577840" cy="3486150"/>
+            <a:ext cx="5577840" cy="3671608"/>
           </a:xfrm>
           <a:prstGeom prst="rect">
             <a:avLst/>
@@ -5336,7 +5336,7 @@
                 <a:ea typeface="Microsoft YaHei" pitchFamily="34" charset="-122"/>
                 <a:cs typeface="Microsoft YaHei" pitchFamily="34" charset="-120"/>
               </a:rPr>
-              <a:t>② 延迟 KPI：对软/硬两种基线的延迟增幅</a:t>
+              <a:t>② 延迟 KPI：P 路并行下的级联时延增幅（权威结论）</a:t>
             </a:r>
             <a:endParaRPr lang="en-US" sz="1350" dirty="0"/>
           </a:p>
@@ -5344,7 +5344,7 @@
       </p:sp>
       <p:pic>
         <p:nvPicPr>
-          <p:cNvPr id="7" name="Image 1" descr="/Users/chenshiyang.10/workspace/llosd_reproduction/rs_bch_cascade/figures/n255_kpi_bars.png">    </p:cNvPr>
+          <p:cNvPr id="7" name="Image 1" descr="/Users/chenshiyang.10/workspace/llosd_reproduction/rs_bch_cascade_matlab/figures/matlab_parallel_kpi.png">    </p:cNvPr>
           <p:cNvPicPr>
             <a:picLocks noChangeAspect="1"/>
           </p:cNvPicPr>
@@ -5359,7 +5359,7 @@
         <p:spPr>
           <a:xfrm>
             <a:off x="6400800" y="1737360"/>
-            <a:ext cx="5242255" cy="1965846"/>
+            <a:ext cx="5242255" cy="2296108"/>
           </a:xfrm>
           <a:prstGeom prst="rect">
             <a:avLst/>
@@ -5374,12 +5374,12 @@
         </p:nvSpPr>
         <p:spPr>
           <a:xfrm>
-            <a:off x="6400800" y="3931806"/>
-            <a:ext cx="5242255" cy="1371600"/>
+            <a:off x="6400800" y="4216348"/>
+            <a:ext cx="5242255" cy="1481328"/>
           </a:xfrm>
           <a:prstGeom prst="roundRect">
             <a:avLst>
-              <a:gd name="adj" fmla="val 6000"/>
+              <a:gd name="adj" fmla="val 5556"/>
             </a:avLst>
           </a:prstGeom>
           <a:solidFill>
@@ -5401,8 +5401,8 @@
         </p:nvSpPr>
         <p:spPr>
           <a:xfrm>
-            <a:off x="6583680" y="4041534"/>
-            <a:ext cx="4876495" cy="310896"/>
+            <a:off x="6583680" y="4307788"/>
+            <a:ext cx="4876495" cy="292608"/>
           </a:xfrm>
           <a:prstGeom prst="rect">
             <a:avLst/>
@@ -5426,7 +5426,7 @@
                 <a:ea typeface="Microsoft YaHei" pitchFamily="34" charset="-122"/>
                 <a:cs typeface="Microsoft YaHei" pitchFamily="34" charset="-120"/>
               </a:rPr>
-              <a:t>延迟结论</a:t>
+              <a:t>延迟结论（权威口径）</a:t>
             </a:r>
             <a:endParaRPr lang="en-US" sz="1300" dirty="0"/>
           </a:p>
@@ -5440,8 +5440,8 @@
         </p:nvSpPr>
         <p:spPr>
           <a:xfrm>
-            <a:off x="6583680" y="4389006"/>
-            <a:ext cx="4876495" cy="868680"/>
+            <a:off x="6583680" y="4636972"/>
+            <a:ext cx="4876495" cy="987552"/>
           </a:xfrm>
           <a:prstGeom prst="rect">
             <a:avLst/>
@@ -5455,12 +5455,12 @@
           <a:p>
             <a:pPr algn="l" indent="0" marL="0">
               <a:lnSpc>
-                <a:spcPct val="115000"/>
+                <a:spcPct val="112000"/>
               </a:lnSpc>
               <a:buNone/>
             </a:pPr>
             <a:r>
-              <a:rPr lang="en-US" sz="1200" dirty="0">
+              <a:rPr lang="en-US" sz="1150" dirty="0">
                 <a:solidFill>
                   <a:srgbClr val="1A1A1A"/>
                 </a:solidFill>
@@ -5468,19 +5468,39 @@
                 <a:ea typeface="Microsoft YaHei" pitchFamily="34" charset="-122"/>
                 <a:cs typeface="Microsoft YaHei" pitchFamily="34" charset="-120"/>
               </a:rPr>
-              <a:t>对软判基线 LCC-BR：低 SNR 延迟 −20%~−27%，KPI（≤+10%）达标；</a:t>
-            </a:r>
-            <a:endParaRPr lang="en-US" sz="1200" dirty="0"/>
+              <a:t>串行 P=1：级联 LLOSD 比纯 RS 高 +18.7%(n=255)/+26.8%(n=127)，略超 10% 线；</a:t>
+            </a:r>
+            <a:endParaRPr lang="en-US" sz="1150" dirty="0"/>
           </a:p>
           <a:p>
             <a:pPr algn="l" indent="0" marL="0">
               <a:lnSpc>
-                <a:spcPct val="115000"/>
+                <a:spcPct val="112000"/>
               </a:lnSpc>
               <a:buNone/>
             </a:pPr>
             <a:r>
-              <a:rPr lang="en-US" sz="1200" dirty="0">
+              <a:rPr lang="en-US" sz="1150" dirty="0">
+                <a:solidFill>
+                  <a:srgbClr val="015C31"/>
+                </a:solidFill>
+                <a:latin typeface="Microsoft YaHei" pitchFamily="34" charset="0"/>
+                <a:ea typeface="Microsoft YaHei" pitchFamily="34" charset="-122"/>
+                <a:cs typeface="Microsoft YaHei" pitchFamily="34" charset="-120"/>
+              </a:rPr>
+              <a:t>LLOSD 无主元、可并行(时延≈ops/P)：P=2→+9.4%、P=3→+8.9%，均达标；</a:t>
+            </a:r>
+            <a:endParaRPr lang="en-US" sz="1150" dirty="0"/>
+          </a:p>
+          <a:p>
+            <a:pPr algn="l" indent="0" marL="0">
+              <a:lnSpc>
+                <a:spcPct val="112000"/>
+              </a:lnSpc>
+              <a:buNone/>
+            </a:pPr>
+            <a:r>
+              <a:rPr lang="en-US" sz="1150" dirty="0">
                 <a:solidFill>
                   <a:srgbClr val="A23E0A"/>
                 </a:solidFill>
@@ -5488,9 +5508,9 @@
                 <a:ea typeface="Microsoft YaHei" pitchFamily="34" charset="-122"/>
                 <a:cs typeface="Microsoft YaHei" pitchFamily="34" charset="-120"/>
               </a:rPr>
-              <a:t>对硬判基线 BM：软判法必然更贵（+1156%~+1285%），需 Direct 硬判路线达标。</a:t>
-            </a:r>
-            <a:endParaRPr lang="en-US" sz="1200" dirty="0"/>
+              <a:t>OSD 高斯消元串行、无法并行 —— 这正是 LLOSD 胜过 OSD 之处。</a:t>
+            </a:r>
+            <a:endParaRPr lang="en-US" sz="1150" dirty="0"/>
           </a:p>
         </p:txBody>
       </p:sp>
@@ -5502,7 +5522,7 @@
         </p:nvSpPr>
         <p:spPr>
           <a:xfrm>
-            <a:off x="548640" y="5177790"/>
+            <a:off x="548640" y="5363248"/>
             <a:ext cx="5577840" cy="1371600"/>
           </a:xfrm>
           <a:prstGeom prst="roundRect">
@@ -5529,7 +5549,7 @@
         </p:nvSpPr>
         <p:spPr>
           <a:xfrm>
-            <a:off x="731520" y="5287518"/>
+            <a:off x="731520" y="5472976"/>
             <a:ext cx="5212080" cy="310896"/>
           </a:xfrm>
           <a:prstGeom prst="rect">
@@ -5568,7 +5588,7 @@
         </p:nvSpPr>
         <p:spPr>
           <a:xfrm>
-            <a:off x="731520" y="5634990"/>
+            <a:off x="731520" y="5820448"/>
             <a:ext cx="5212080" cy="868680"/>
           </a:xfrm>
           <a:prstGeom prst="rect">
@@ -6264,7 +6284,7 @@
                 <a:ea typeface="Microsoft YaHei" pitchFamily="34" charset="-122"/>
                 <a:cs typeface="Microsoft YaHei" pitchFamily="34" charset="-120"/>
               </a:rPr>
-              <a:t>开销约 12%（外码 RS × 内码 BCH 码率）；延迟对软判基线达标、对硬判基线偏贵；BER 低 SNR 有门限、高 SNR 反超；内码建议 t≥2。</a:t>
+              <a:t>开销约 12%（外码 RS × 内码 BCH 码率）；延迟权威口径：串行 P=1 +18.7%(n=255)/+26.8%(n=127)，无主元可并行下 P=2/P=3 即降到 ≤10% KPI 达标；BER 低 SNR 有门限、高 SNR 反超；内码建议 t≥2。</a:t>
             </a:r>
             <a:endParaRPr lang="en-US" sz="1300" dirty="0"/>
           </a:p>
@@ -6350,7 +6370,7 @@
                 <a:ea typeface="Microsoft YaHei" pitchFamily="34" charset="-122"/>
                 <a:cs typeface="Microsoft YaHei" pitchFamily="34" charset="-120"/>
               </a:rPr>
-              <a:t>① 内码升到 BCH t≥2 提升级联增益；② P=64 并行 + Lagrange 共享压延迟；③ 补软判 Chase 交织增益。</a:t>
+              <a:t>① 内码升到 BCH t≥2 提升级联增益；② 用 P=2(n=255)/P=3(n=127) 的无主元并行 LLOSD 压延迟达标（更高 P 有更多余量）；③ 补软判 Chase 交织增益。</a:t>
             </a:r>
             <a:endParaRPr lang="en-US" sz="1200" dirty="0"/>
           </a:p>

</xml_diff>